<commit_message>
wip: adjust ppt plot layout
</commit_message>
<xml_diff>
--- a/output/Sigma_Summary_Latest.pptx
+++ b/output/Sigma_Summary_Latest.pptx
@@ -9842,8 +9842,8 @@
         </p:blipFill>
         <p:spPr>
           <a:xfrm>
-            <a:off x="457200" y="1097280"/>
-            <a:ext cx="2818638" cy="2651760"/>
+            <a:off x="868680" y="2240280"/>
+            <a:ext cx="2558034" cy="1975104"/>
           </a:xfrm>
           <a:prstGeom prst="rect">
             <a:avLst/>
@@ -9868,8 +9868,8 @@
         </p:blipFill>
         <p:spPr>
           <a:xfrm>
-            <a:off x="3275838" y="1097280"/>
-            <a:ext cx="2818638" cy="2651760"/>
+            <a:off x="3499866" y="2240280"/>
+            <a:ext cx="2558034" cy="1975104"/>
           </a:xfrm>
           <a:prstGeom prst="rect">
             <a:avLst/>
@@ -9894,8 +9894,8 @@
         </p:blipFill>
         <p:spPr>
           <a:xfrm>
-            <a:off x="6094476" y="1097280"/>
-            <a:ext cx="2818638" cy="2651760"/>
+            <a:off x="6131052" y="2240280"/>
+            <a:ext cx="2558034" cy="1975104"/>
           </a:xfrm>
           <a:prstGeom prst="rect">
             <a:avLst/>
@@ -9920,8 +9920,8 @@
         </p:blipFill>
         <p:spPr>
           <a:xfrm>
-            <a:off x="8913114" y="1097280"/>
-            <a:ext cx="2818638" cy="2651760"/>
+            <a:off x="8762238" y="2240280"/>
+            <a:ext cx="2558034" cy="1975104"/>
           </a:xfrm>
           <a:prstGeom prst="rect">
             <a:avLst/>
@@ -9946,8 +9946,8 @@
         </p:blipFill>
         <p:spPr>
           <a:xfrm>
-            <a:off x="457200" y="3749040"/>
-            <a:ext cx="2818638" cy="2651760"/>
+            <a:off x="868680" y="4288536"/>
+            <a:ext cx="2558034" cy="1975104"/>
           </a:xfrm>
           <a:prstGeom prst="rect">
             <a:avLst/>
@@ -9972,8 +9972,8 @@
         </p:blipFill>
         <p:spPr>
           <a:xfrm>
-            <a:off x="3275838" y="3749040"/>
-            <a:ext cx="2818638" cy="2651760"/>
+            <a:off x="3499866" y="4288536"/>
+            <a:ext cx="2558034" cy="1975104"/>
           </a:xfrm>
           <a:prstGeom prst="rect">
             <a:avLst/>
@@ -9998,8 +9998,8 @@
         </p:blipFill>
         <p:spPr>
           <a:xfrm>
-            <a:off x="6094476" y="3749040"/>
-            <a:ext cx="2818638" cy="2651760"/>
+            <a:off x="6131052" y="4288536"/>
+            <a:ext cx="2558034" cy="1975104"/>
           </a:xfrm>
           <a:prstGeom prst="rect">
             <a:avLst/>
@@ -10024,8 +10024,8 @@
         </p:blipFill>
         <p:spPr>
           <a:xfrm>
-            <a:off x="8913114" y="3749040"/>
-            <a:ext cx="2818638" cy="2651760"/>
+            <a:off x="8762238" y="4288536"/>
+            <a:ext cx="2558034" cy="1975104"/>
           </a:xfrm>
           <a:prstGeom prst="rect">
             <a:avLst/>
@@ -10102,8 +10102,8 @@
         </p:blipFill>
         <p:spPr>
           <a:xfrm>
-            <a:off x="457200" y="1097280"/>
-            <a:ext cx="2818638" cy="2651760"/>
+            <a:off x="868680" y="2240280"/>
+            <a:ext cx="2558034" cy="1975104"/>
           </a:xfrm>
           <a:prstGeom prst="rect">
             <a:avLst/>
@@ -10128,8 +10128,8 @@
         </p:blipFill>
         <p:spPr>
           <a:xfrm>
-            <a:off x="3275838" y="1097280"/>
-            <a:ext cx="2818638" cy="2651760"/>
+            <a:off x="3499866" y="2240280"/>
+            <a:ext cx="2558034" cy="1975104"/>
           </a:xfrm>
           <a:prstGeom prst="rect">
             <a:avLst/>
@@ -10154,8 +10154,8 @@
         </p:blipFill>
         <p:spPr>
           <a:xfrm>
-            <a:off x="6094476" y="1097280"/>
-            <a:ext cx="2818638" cy="2651760"/>
+            <a:off x="6131052" y="2240280"/>
+            <a:ext cx="2558034" cy="1975104"/>
           </a:xfrm>
           <a:prstGeom prst="rect">
             <a:avLst/>
@@ -10180,8 +10180,8 @@
         </p:blipFill>
         <p:spPr>
           <a:xfrm>
-            <a:off x="8913114" y="1097280"/>
-            <a:ext cx="2818638" cy="2651760"/>
+            <a:off x="8762238" y="2240280"/>
+            <a:ext cx="2558034" cy="1975104"/>
           </a:xfrm>
           <a:prstGeom prst="rect">
             <a:avLst/>
@@ -10206,8 +10206,8 @@
         </p:blipFill>
         <p:spPr>
           <a:xfrm>
-            <a:off x="457200" y="3749040"/>
-            <a:ext cx="2818638" cy="2651760"/>
+            <a:off x="868680" y="4288536"/>
+            <a:ext cx="2558034" cy="1975104"/>
           </a:xfrm>
           <a:prstGeom prst="rect">
             <a:avLst/>
@@ -10232,8 +10232,8 @@
         </p:blipFill>
         <p:spPr>
           <a:xfrm>
-            <a:off x="3275838" y="3749040"/>
-            <a:ext cx="2818638" cy="2651760"/>
+            <a:off x="3499866" y="4288536"/>
+            <a:ext cx="2558034" cy="1975104"/>
           </a:xfrm>
           <a:prstGeom prst="rect">
             <a:avLst/>
@@ -10258,8 +10258,8 @@
         </p:blipFill>
         <p:spPr>
           <a:xfrm>
-            <a:off x="6094476" y="3749040"/>
-            <a:ext cx="2818638" cy="2651760"/>
+            <a:off x="6131052" y="4288536"/>
+            <a:ext cx="2558034" cy="1975104"/>
           </a:xfrm>
           <a:prstGeom prst="rect">
             <a:avLst/>
@@ -10284,8 +10284,8 @@
         </p:blipFill>
         <p:spPr>
           <a:xfrm>
-            <a:off x="8913114" y="3749040"/>
-            <a:ext cx="2818638" cy="2651760"/>
+            <a:off x="8762238" y="4288536"/>
+            <a:ext cx="2558034" cy="1975104"/>
           </a:xfrm>
           <a:prstGeom prst="rect">
             <a:avLst/>
@@ -10362,8 +10362,8 @@
         </p:blipFill>
         <p:spPr>
           <a:xfrm>
-            <a:off x="457200" y="1097280"/>
-            <a:ext cx="2818638" cy="2651760"/>
+            <a:off x="868680" y="2240280"/>
+            <a:ext cx="2558034" cy="1975104"/>
           </a:xfrm>
           <a:prstGeom prst="rect">
             <a:avLst/>
@@ -10388,8 +10388,8 @@
         </p:blipFill>
         <p:spPr>
           <a:xfrm>
-            <a:off x="3275838" y="1097280"/>
-            <a:ext cx="2818638" cy="2651760"/>
+            <a:off x="3499866" y="2240280"/>
+            <a:ext cx="2558034" cy="1975104"/>
           </a:xfrm>
           <a:prstGeom prst="rect">
             <a:avLst/>
@@ -10414,8 +10414,8 @@
         </p:blipFill>
         <p:spPr>
           <a:xfrm>
-            <a:off x="6094476" y="1097280"/>
-            <a:ext cx="2818638" cy="2651760"/>
+            <a:off x="6131052" y="2240280"/>
+            <a:ext cx="2558034" cy="1975104"/>
           </a:xfrm>
           <a:prstGeom prst="rect">
             <a:avLst/>
@@ -10440,8 +10440,8 @@
         </p:blipFill>
         <p:spPr>
           <a:xfrm>
-            <a:off x="8913114" y="1097280"/>
-            <a:ext cx="2818638" cy="2651760"/>
+            <a:off x="8762238" y="2240280"/>
+            <a:ext cx="2558034" cy="1975104"/>
           </a:xfrm>
           <a:prstGeom prst="rect">
             <a:avLst/>
@@ -10466,8 +10466,8 @@
         </p:blipFill>
         <p:spPr>
           <a:xfrm>
-            <a:off x="457200" y="3749040"/>
-            <a:ext cx="2818638" cy="2651760"/>
+            <a:off x="868680" y="4288536"/>
+            <a:ext cx="2558034" cy="1975104"/>
           </a:xfrm>
           <a:prstGeom prst="rect">
             <a:avLst/>
@@ -10492,8 +10492,8 @@
         </p:blipFill>
         <p:spPr>
           <a:xfrm>
-            <a:off x="3275838" y="3749040"/>
-            <a:ext cx="2818638" cy="2651760"/>
+            <a:off x="3499866" y="4288536"/>
+            <a:ext cx="2558034" cy="1975104"/>
           </a:xfrm>
           <a:prstGeom prst="rect">
             <a:avLst/>
@@ -10518,8 +10518,8 @@
         </p:blipFill>
         <p:spPr>
           <a:xfrm>
-            <a:off x="6094476" y="3749040"/>
-            <a:ext cx="2818638" cy="2651760"/>
+            <a:off x="6131052" y="4288536"/>
+            <a:ext cx="2558034" cy="1975104"/>
           </a:xfrm>
           <a:prstGeom prst="rect">
             <a:avLst/>
@@ -10544,8 +10544,8 @@
         </p:blipFill>
         <p:spPr>
           <a:xfrm>
-            <a:off x="8913114" y="3749040"/>
-            <a:ext cx="2818638" cy="2651760"/>
+            <a:off x="8762238" y="4288536"/>
+            <a:ext cx="2558034" cy="1975104"/>
           </a:xfrm>
           <a:prstGeom prst="rect">
             <a:avLst/>
@@ -10622,8 +10622,8 @@
         </p:blipFill>
         <p:spPr>
           <a:xfrm>
-            <a:off x="457200" y="1097280"/>
-            <a:ext cx="2818638" cy="2651760"/>
+            <a:off x="868680" y="2240280"/>
+            <a:ext cx="2558034" cy="1975104"/>
           </a:xfrm>
           <a:prstGeom prst="rect">
             <a:avLst/>
@@ -10648,8 +10648,8 @@
         </p:blipFill>
         <p:spPr>
           <a:xfrm>
-            <a:off x="3275838" y="1097280"/>
-            <a:ext cx="2818638" cy="2651760"/>
+            <a:off x="3499866" y="2240280"/>
+            <a:ext cx="2558034" cy="1975104"/>
           </a:xfrm>
           <a:prstGeom prst="rect">
             <a:avLst/>
@@ -10674,8 +10674,8 @@
         </p:blipFill>
         <p:spPr>
           <a:xfrm>
-            <a:off x="6094476" y="1097280"/>
-            <a:ext cx="2818638" cy="2651760"/>
+            <a:off x="6131052" y="2240280"/>
+            <a:ext cx="2558034" cy="1975104"/>
           </a:xfrm>
           <a:prstGeom prst="rect">
             <a:avLst/>
@@ -10700,8 +10700,8 @@
         </p:blipFill>
         <p:spPr>
           <a:xfrm>
-            <a:off x="8913114" y="1097280"/>
-            <a:ext cx="2818638" cy="2651760"/>
+            <a:off x="8762238" y="2240280"/>
+            <a:ext cx="2558034" cy="1975104"/>
           </a:xfrm>
           <a:prstGeom prst="rect">
             <a:avLst/>
@@ -10726,8 +10726,8 @@
         </p:blipFill>
         <p:spPr>
           <a:xfrm>
-            <a:off x="457200" y="3749040"/>
-            <a:ext cx="2818638" cy="2651760"/>
+            <a:off x="868680" y="4288536"/>
+            <a:ext cx="2558034" cy="1975104"/>
           </a:xfrm>
           <a:prstGeom prst="rect">
             <a:avLst/>
@@ -10752,8 +10752,8 @@
         </p:blipFill>
         <p:spPr>
           <a:xfrm>
-            <a:off x="3275838" y="3749040"/>
-            <a:ext cx="2818638" cy="2651760"/>
+            <a:off x="3499866" y="4288536"/>
+            <a:ext cx="2558034" cy="1975104"/>
           </a:xfrm>
           <a:prstGeom prst="rect">
             <a:avLst/>
@@ -10778,8 +10778,8 @@
         </p:blipFill>
         <p:spPr>
           <a:xfrm>
-            <a:off x="6094476" y="3749040"/>
-            <a:ext cx="2818638" cy="2651760"/>
+            <a:off x="6131052" y="4288536"/>
+            <a:ext cx="2558034" cy="1975104"/>
           </a:xfrm>
           <a:prstGeom prst="rect">
             <a:avLst/>
@@ -10804,8 +10804,8 @@
         </p:blipFill>
         <p:spPr>
           <a:xfrm>
-            <a:off x="8913114" y="3749040"/>
-            <a:ext cx="2818638" cy="2651760"/>
+            <a:off x="8762238" y="4288536"/>
+            <a:ext cx="2558034" cy="1975104"/>
           </a:xfrm>
           <a:prstGeom prst="rect">
             <a:avLst/>
@@ -10882,8 +10882,8 @@
         </p:blipFill>
         <p:spPr>
           <a:xfrm>
-            <a:off x="457200" y="1097280"/>
-            <a:ext cx="2818638" cy="2651760"/>
+            <a:off x="868680" y="2240280"/>
+            <a:ext cx="2558034" cy="1975104"/>
           </a:xfrm>
           <a:prstGeom prst="rect">
             <a:avLst/>
@@ -10908,8 +10908,8 @@
         </p:blipFill>
         <p:spPr>
           <a:xfrm>
-            <a:off x="3275838" y="1097280"/>
-            <a:ext cx="2818638" cy="2651760"/>
+            <a:off x="3499866" y="2240280"/>
+            <a:ext cx="2558034" cy="1975104"/>
           </a:xfrm>
           <a:prstGeom prst="rect">
             <a:avLst/>
@@ -10934,8 +10934,8 @@
         </p:blipFill>
         <p:spPr>
           <a:xfrm>
-            <a:off x="6094476" y="1097280"/>
-            <a:ext cx="2818638" cy="2651760"/>
+            <a:off x="6131052" y="2240280"/>
+            <a:ext cx="2558034" cy="1975104"/>
           </a:xfrm>
           <a:prstGeom prst="rect">
             <a:avLst/>
@@ -10960,8 +10960,8 @@
         </p:blipFill>
         <p:spPr>
           <a:xfrm>
-            <a:off x="8913114" y="1097280"/>
-            <a:ext cx="2818638" cy="2651760"/>
+            <a:off x="8762238" y="2240280"/>
+            <a:ext cx="2558034" cy="1975104"/>
           </a:xfrm>
           <a:prstGeom prst="rect">
             <a:avLst/>
@@ -10986,8 +10986,8 @@
         </p:blipFill>
         <p:spPr>
           <a:xfrm>
-            <a:off x="457200" y="3749040"/>
-            <a:ext cx="2818638" cy="2651760"/>
+            <a:off x="868680" y="4288536"/>
+            <a:ext cx="2558034" cy="1975104"/>
           </a:xfrm>
           <a:prstGeom prst="rect">
             <a:avLst/>
@@ -11012,8 +11012,8 @@
         </p:blipFill>
         <p:spPr>
           <a:xfrm>
-            <a:off x="3275838" y="3749040"/>
-            <a:ext cx="2818638" cy="2651760"/>
+            <a:off x="3499866" y="4288536"/>
+            <a:ext cx="2558034" cy="1975104"/>
           </a:xfrm>
           <a:prstGeom prst="rect">
             <a:avLst/>
@@ -11038,8 +11038,8 @@
         </p:blipFill>
         <p:spPr>
           <a:xfrm>
-            <a:off x="6094476" y="3749040"/>
-            <a:ext cx="2818638" cy="2651760"/>
+            <a:off x="6131052" y="4288536"/>
+            <a:ext cx="2558034" cy="1975104"/>
           </a:xfrm>
           <a:prstGeom prst="rect">
             <a:avLst/>
@@ -11064,8 +11064,8 @@
         </p:blipFill>
         <p:spPr>
           <a:xfrm>
-            <a:off x="8913114" y="3749040"/>
-            <a:ext cx="2818638" cy="2651760"/>
+            <a:off x="8762238" y="4288536"/>
+            <a:ext cx="2558034" cy="1975104"/>
           </a:xfrm>
           <a:prstGeom prst="rect">
             <a:avLst/>

</xml_diff>